<commit_message>
[2026.03.06.금] : 아이템 추가
</commit_message>
<xml_diff>
--- a/FashionGame_MyStyle/assets/편집.pptx
+++ b/FashionGame_MyStyle/assets/편집.pptx
@@ -198,7 +198,7 @@
           <a:p>
             <a:fld id="{735E9D12-1D51-4C5A-9100-BEF5B44C6E9F}" type="datetimeFigureOut">
               <a:rPr lang="ko-KR" altLang="en-US" smtClean="0"/>
-              <a:t>2026-03-02-Mon</a:t>
+              <a:t>2026-03-05-Thu</a:t>
             </a:fld>
             <a:endParaRPr lang="ko-KR" altLang="en-US"/>
           </a:p>
@@ -696,7 +696,7 @@
           <a:p>
             <a:fld id="{D9F17D16-5A3B-479C-971A-D492ADD6ED98}" type="datetimeFigureOut">
               <a:rPr lang="ko-KR" altLang="en-US" smtClean="0"/>
-              <a:t>2026-03-02-Mon</a:t>
+              <a:t>2026-03-05-Thu</a:t>
             </a:fld>
             <a:endParaRPr lang="ko-KR" altLang="en-US"/>
           </a:p>
@@ -894,7 +894,7 @@
           <a:p>
             <a:fld id="{D9F17D16-5A3B-479C-971A-D492ADD6ED98}" type="datetimeFigureOut">
               <a:rPr lang="ko-KR" altLang="en-US" smtClean="0"/>
-              <a:t>2026-03-02-Mon</a:t>
+              <a:t>2026-03-05-Thu</a:t>
             </a:fld>
             <a:endParaRPr lang="ko-KR" altLang="en-US"/>
           </a:p>
@@ -1102,7 +1102,7 @@
           <a:p>
             <a:fld id="{D9F17D16-5A3B-479C-971A-D492ADD6ED98}" type="datetimeFigureOut">
               <a:rPr lang="ko-KR" altLang="en-US" smtClean="0"/>
-              <a:t>2026-03-02-Mon</a:t>
+              <a:t>2026-03-05-Thu</a:t>
             </a:fld>
             <a:endParaRPr lang="ko-KR" altLang="en-US"/>
           </a:p>
@@ -1300,7 +1300,7 @@
           <a:p>
             <a:fld id="{D9F17D16-5A3B-479C-971A-D492ADD6ED98}" type="datetimeFigureOut">
               <a:rPr lang="ko-KR" altLang="en-US" smtClean="0"/>
-              <a:t>2026-03-02-Mon</a:t>
+              <a:t>2026-03-05-Thu</a:t>
             </a:fld>
             <a:endParaRPr lang="ko-KR" altLang="en-US"/>
           </a:p>
@@ -1575,7 +1575,7 @@
           <a:p>
             <a:fld id="{D9F17D16-5A3B-479C-971A-D492ADD6ED98}" type="datetimeFigureOut">
               <a:rPr lang="ko-KR" altLang="en-US" smtClean="0"/>
-              <a:t>2026-03-02-Mon</a:t>
+              <a:t>2026-03-05-Thu</a:t>
             </a:fld>
             <a:endParaRPr lang="ko-KR" altLang="en-US"/>
           </a:p>
@@ -1840,7 +1840,7 @@
           <a:p>
             <a:fld id="{D9F17D16-5A3B-479C-971A-D492ADD6ED98}" type="datetimeFigureOut">
               <a:rPr lang="ko-KR" altLang="en-US" smtClean="0"/>
-              <a:t>2026-03-02-Mon</a:t>
+              <a:t>2026-03-05-Thu</a:t>
             </a:fld>
             <a:endParaRPr lang="ko-KR" altLang="en-US"/>
           </a:p>
@@ -2252,7 +2252,7 @@
           <a:p>
             <a:fld id="{D9F17D16-5A3B-479C-971A-D492ADD6ED98}" type="datetimeFigureOut">
               <a:rPr lang="ko-KR" altLang="en-US" smtClean="0"/>
-              <a:t>2026-03-02-Mon</a:t>
+              <a:t>2026-03-05-Thu</a:t>
             </a:fld>
             <a:endParaRPr lang="ko-KR" altLang="en-US"/>
           </a:p>
@@ -2393,7 +2393,7 @@
           <a:p>
             <a:fld id="{D9F17D16-5A3B-479C-971A-D492ADD6ED98}" type="datetimeFigureOut">
               <a:rPr lang="ko-KR" altLang="en-US" smtClean="0"/>
-              <a:t>2026-03-02-Mon</a:t>
+              <a:t>2026-03-05-Thu</a:t>
             </a:fld>
             <a:endParaRPr lang="ko-KR" altLang="en-US"/>
           </a:p>
@@ -2506,7 +2506,7 @@
           <a:p>
             <a:fld id="{D9F17D16-5A3B-479C-971A-D492ADD6ED98}" type="datetimeFigureOut">
               <a:rPr lang="ko-KR" altLang="en-US" smtClean="0"/>
-              <a:t>2026-03-02-Mon</a:t>
+              <a:t>2026-03-05-Thu</a:t>
             </a:fld>
             <a:endParaRPr lang="ko-KR" altLang="en-US"/>
           </a:p>
@@ -2817,7 +2817,7 @@
           <a:p>
             <a:fld id="{D9F17D16-5A3B-479C-971A-D492ADD6ED98}" type="datetimeFigureOut">
               <a:rPr lang="ko-KR" altLang="en-US" smtClean="0"/>
-              <a:t>2026-03-02-Mon</a:t>
+              <a:t>2026-03-05-Thu</a:t>
             </a:fld>
             <a:endParaRPr lang="ko-KR" altLang="en-US"/>
           </a:p>
@@ -3105,7 +3105,7 @@
           <a:p>
             <a:fld id="{D9F17D16-5A3B-479C-971A-D492ADD6ED98}" type="datetimeFigureOut">
               <a:rPr lang="ko-KR" altLang="en-US" smtClean="0"/>
-              <a:t>2026-03-02-Mon</a:t>
+              <a:t>2026-03-05-Thu</a:t>
             </a:fld>
             <a:endParaRPr lang="ko-KR" altLang="en-US"/>
           </a:p>
@@ -3346,7 +3346,7 @@
           <a:p>
             <a:fld id="{D9F17D16-5A3B-479C-971A-D492ADD6ED98}" type="datetimeFigureOut">
               <a:rPr lang="ko-KR" altLang="en-US" smtClean="0"/>
-              <a:t>2026-03-02-Mon</a:t>
+              <a:t>2026-03-05-Thu</a:t>
             </a:fld>
             <a:endParaRPr lang="ko-KR" altLang="en-US"/>
           </a:p>

</xml_diff>